<commit_message>
PAUSED (task166): stage 4 round 1 reworked, every construction in the $10 million bin's middle half, waiting on a fresh reader and judge
The extension response sharpened around a refinance cover of 1.10 and the push
written half as cash-out deals, half as lower-leverage refinances: nineteen
constructions of the decisive step (bands, the data-chosen cuts 1.08 to 1.11,
the debt yield since 2023, the debt yield with the rate, the 2027 balloons
only) file 148.3 to 150.9 with their hold-out scores; the 1.25 convention, the
note-rate DSCR, the debt yield on all history, the wall's share carried to
every balloon and every balloon extended stay outside the bin. The loss is
graded to the nearest $10 million, the overlay's start is filed in the prompt,
and the extract notes file the two facts that settle Ask A's devices.

Co-Authored-By: Claude Opus 5.5 <noreply@anthropic.com>
Claude-Session: https://claude.ai/code/session_01A6XcFx5t62c7gPi1bBKcVi
</commit_message>
<xml_diff>
--- a/task166/golden/overlay_designation_alco.pptx
+++ b/task166/golden/overlay_designation_alco.pptx
@@ -3477,7 +3477,7 @@
               </a:defRPr>
             </a:pPr>
             <a:r>
-              <a:t>Averaged +200 bp loss in economic value over the month-ends of 2027: $150 million (to the nearest $25 million)</a:t>
+              <a:t>Averaged +200 bp loss in economic value over the month-ends of 2027: $150 million (to the nearest $10 million)</a:t>
             </a:r>
           </a:p>
         </p:txBody>
@@ -3516,7 +3516,7 @@
               </a:defRPr>
             </a:pPr>
             <a:r>
-              <a:t>About $3.0 billion of the pool's balloons fall due from December 2026 to December 2027, most of them written in the early-2022 push at full leverage. At the planning cycle's 6.95 per cent few can carry a new loan of their balance; about four-fifths of that principal is expected to extend for 36 months at its note rate.</a:t>
+              <a:t>About $4.7 billion of the pool's balloons fall due from December 2026 to December 2027, most of them written in the early-2022 push. At the planning cycle's 6.95 per cent the push's cash-out loans, sized at full leverage on pro forma rents, cannot carry a new loan of their balance; about three-fifths of that principal is expected to extend for 36 months at its note rate.</a:t>
             </a:r>
           </a:p>
           <a:p>
@@ -3648,7 +3648,7 @@
                         <a:defRPr sz="1300" b="1"/>
                       </a:pPr>
                       <a:r>
-                        <a:t>3.89</a:t>
+                        <a:t>5.29</a:t>
                       </a:r>
                     </a:p>
                   </a:txBody>
@@ -3757,7 +3757,7 @@
                         <a:defRPr sz="1300" b="0"/>
                       </a:pPr>
                       <a:r>
-                        <a:t>85</a:t>
+                        <a:t>90</a:t>
                       </a:r>
                     </a:p>
                   </a:txBody>
@@ -3804,7 +3804,7 @@
                         <a:defRPr sz="1300" b="0"/>
                       </a:pPr>
                       <a:r>
-                        <a:t>65</a:t>
+                        <a:t>70</a:t>
                       </a:r>
                     </a:p>
                   </a:txBody>
@@ -3896,7 +3896,7 @@
               </a:defRPr>
             </a:pPr>
             <a:r>
-              <a:t>Losses to the nearest $5 million; principal at 30 November 2026.</a:t>
+              <a:t>Losses to the nearest $10 million; principal at 30 November 2026.</a:t>
             </a:r>
           </a:p>
         </p:txBody>
@@ -3935,7 +3935,7 @@
               </a:defRPr>
             </a:pPr>
             <a:r>
-              <a:t>Trade Tuesday 15 December 2026, effective Monday 4 January 2027, maturity Monday 6 January 2031.</a:t>
+              <a:t>$1.2 billion pay-fixed for four years: trades Tuesday 15 December 2026, starts Monday 4 January 2027.</a:t>
             </a:r>
           </a:p>
         </p:txBody>

</xml_diff>